<commit_message>
Précision défausse au Cimetière pour construire un Donjon ; fin traduction en anglais des cartes
</commit_message>
<xml_diff>
--- a/pictures/Deck-fr/Deck-fr.pptx
+++ b/pictures/Deck-fr/Deck-fr.pptx
@@ -203,7 +203,7 @@
           <a:p>
             <a:fld id="{263B0988-6DB9-4E3D-B7FD-EFF3BCABE954}" type="datetimeFigureOut">
               <a:rPr lang="fr-FR" smtClean="0"/>
-              <a:t>12/04/2026</a:t>
+              <a:t>17/04/2026</a:t>
             </a:fld>
             <a:endParaRPr lang="fr-FR"/>
           </a:p>
@@ -701,7 +701,7 @@
           <a:p>
             <a:fld id="{588505E2-0C4C-443F-8F57-41958F504CA2}" type="datetimeFigureOut">
               <a:rPr lang="fr-FR" smtClean="0"/>
-              <a:t>12/04/2026</a:t>
+              <a:t>17/04/2026</a:t>
             </a:fld>
             <a:endParaRPr lang="fr-FR"/>
           </a:p>
@@ -899,7 +899,7 @@
           <a:p>
             <a:fld id="{588505E2-0C4C-443F-8F57-41958F504CA2}" type="datetimeFigureOut">
               <a:rPr lang="fr-FR" smtClean="0"/>
-              <a:t>12/04/2026</a:t>
+              <a:t>17/04/2026</a:t>
             </a:fld>
             <a:endParaRPr lang="fr-FR"/>
           </a:p>
@@ -1107,7 +1107,7 @@
           <a:p>
             <a:fld id="{588505E2-0C4C-443F-8F57-41958F504CA2}" type="datetimeFigureOut">
               <a:rPr lang="fr-FR" smtClean="0"/>
-              <a:t>12/04/2026</a:t>
+              <a:t>17/04/2026</a:t>
             </a:fld>
             <a:endParaRPr lang="fr-FR"/>
           </a:p>
@@ -1305,7 +1305,7 @@
           <a:p>
             <a:fld id="{588505E2-0C4C-443F-8F57-41958F504CA2}" type="datetimeFigureOut">
               <a:rPr lang="fr-FR" smtClean="0"/>
-              <a:t>12/04/2026</a:t>
+              <a:t>17/04/2026</a:t>
             </a:fld>
             <a:endParaRPr lang="fr-FR"/>
           </a:p>
@@ -1580,7 +1580,7 @@
           <a:p>
             <a:fld id="{588505E2-0C4C-443F-8F57-41958F504CA2}" type="datetimeFigureOut">
               <a:rPr lang="fr-FR" smtClean="0"/>
-              <a:t>12/04/2026</a:t>
+              <a:t>17/04/2026</a:t>
             </a:fld>
             <a:endParaRPr lang="fr-FR"/>
           </a:p>
@@ -1845,7 +1845,7 @@
           <a:p>
             <a:fld id="{588505E2-0C4C-443F-8F57-41958F504CA2}" type="datetimeFigureOut">
               <a:rPr lang="fr-FR" smtClean="0"/>
-              <a:t>12/04/2026</a:t>
+              <a:t>17/04/2026</a:t>
             </a:fld>
             <a:endParaRPr lang="fr-FR"/>
           </a:p>
@@ -2257,7 +2257,7 @@
           <a:p>
             <a:fld id="{588505E2-0C4C-443F-8F57-41958F504CA2}" type="datetimeFigureOut">
               <a:rPr lang="fr-FR" smtClean="0"/>
-              <a:t>12/04/2026</a:t>
+              <a:t>17/04/2026</a:t>
             </a:fld>
             <a:endParaRPr lang="fr-FR"/>
           </a:p>
@@ -2398,7 +2398,7 @@
           <a:p>
             <a:fld id="{588505E2-0C4C-443F-8F57-41958F504CA2}" type="datetimeFigureOut">
               <a:rPr lang="fr-FR" smtClean="0"/>
-              <a:t>12/04/2026</a:t>
+              <a:t>17/04/2026</a:t>
             </a:fld>
             <a:endParaRPr lang="fr-FR"/>
           </a:p>
@@ -2511,7 +2511,7 @@
           <a:p>
             <a:fld id="{588505E2-0C4C-443F-8F57-41958F504CA2}" type="datetimeFigureOut">
               <a:rPr lang="fr-FR" smtClean="0"/>
-              <a:t>12/04/2026</a:t>
+              <a:t>17/04/2026</a:t>
             </a:fld>
             <a:endParaRPr lang="fr-FR"/>
           </a:p>
@@ -2822,7 +2822,7 @@
           <a:p>
             <a:fld id="{588505E2-0C4C-443F-8F57-41958F504CA2}" type="datetimeFigureOut">
               <a:rPr lang="fr-FR" smtClean="0"/>
-              <a:t>12/04/2026</a:t>
+              <a:t>17/04/2026</a:t>
             </a:fld>
             <a:endParaRPr lang="fr-FR"/>
           </a:p>
@@ -3110,7 +3110,7 @@
           <a:p>
             <a:fld id="{588505E2-0C4C-443F-8F57-41958F504CA2}" type="datetimeFigureOut">
               <a:rPr lang="fr-FR" smtClean="0"/>
-              <a:t>12/04/2026</a:t>
+              <a:t>17/04/2026</a:t>
             </a:fld>
             <a:endParaRPr lang="fr-FR"/>
           </a:p>
@@ -3351,7 +3351,7 @@
           <a:p>
             <a:fld id="{588505E2-0C4C-443F-8F57-41958F504CA2}" type="datetimeFigureOut">
               <a:rPr lang="fr-FR" smtClean="0"/>
-              <a:t>12/04/2026</a:t>
+              <a:t>17/04/2026</a:t>
             </a:fld>
             <a:endParaRPr lang="fr-FR"/>
           </a:p>
@@ -13752,7 +13752,7 @@
           <p:spPr>
             <a:xfrm>
               <a:off x="1607355" y="1968526"/>
-              <a:ext cx="1612957" cy="1015663"/>
+              <a:ext cx="1612957" cy="1200329"/>
             </a:xfrm>
             <a:prstGeom prst="rect">
               <a:avLst/>
@@ -13773,26 +13773,7 @@
                   <a:latin typeface="Segoe UI" panose="020B0502040204020203" pitchFamily="34" charset="0"/>
                   <a:cs typeface="Segoe UI" panose="020B0502040204020203" pitchFamily="34" charset="0"/>
                 </a:rPr>
-                <a:t>Défausser 3 troupes de la tuile de commandement pour construire</a:t>
-              </a:r>
-              <a:br>
-                <a:rPr lang="fr-FR" sz="1200" b="1" dirty="0">
-                  <a:solidFill>
-                    <a:schemeClr val="bg1"/>
-                  </a:solidFill>
-                  <a:latin typeface="Segoe UI" panose="020B0502040204020203" pitchFamily="34" charset="0"/>
-                  <a:cs typeface="Segoe UI" panose="020B0502040204020203" pitchFamily="34" charset="0"/>
-                </a:rPr>
-              </a:br>
-              <a:r>
-                <a:rPr lang="fr-FR" sz="1200" b="1" dirty="0">
-                  <a:solidFill>
-                    <a:schemeClr val="bg1"/>
-                  </a:solidFill>
-                  <a:latin typeface="Segoe UI" panose="020B0502040204020203" pitchFamily="34" charset="0"/>
-                  <a:cs typeface="Segoe UI" panose="020B0502040204020203" pitchFamily="34" charset="0"/>
-                </a:rPr>
-                <a:t>un donjon</a:t>
+                <a:t>Défausser 3 troupes de la Tuile de Commandement vers le Cimetière pour y placer un Donjon</a:t>
               </a:r>
             </a:p>
           </p:txBody>
@@ -14309,7 +14290,7 @@
           </p:blipFill>
           <p:spPr>
             <a:xfrm>
-              <a:off x="3172545" y="2080248"/>
+              <a:off x="3056338" y="2237030"/>
               <a:ext cx="375375" cy="837672"/>
             </a:xfrm>
             <a:prstGeom prst="rect">

</xml_diff>